<commit_message>
docs(slides): sync preflight slide with Lab 0 smoke test
The markdown already told the room to run the tool-call cell;
the committed deck still said preflight() alone.

Co-authored-by: Cursor <cursoragent@cursor.com>
</commit_message>
<xml_diff>
--- a/presentation/ai-handson-lab.pptx
+++ b/presentation/ai-handson-lab.pptx
@@ -28659,7 +28659,7 @@
         </p:nvSpPr>
         <p:spPr>
           <a:xfrm>
-            <a:off x="987552" y="2599563"/>
+            <a:off x="987552" y="2344293"/>
             <a:ext cx="457200" cy="328422"/>
           </a:xfrm>
           <a:prstGeom prst="rect">
@@ -28698,7 +28698,7 @@
         </p:nvSpPr>
         <p:spPr>
           <a:xfrm>
-            <a:off x="1499616" y="2599563"/>
+            <a:off x="1499616" y="2344293"/>
             <a:ext cx="4271620" cy="875538"/>
           </a:xfrm>
           <a:prstGeom prst="rect">
@@ -28723,7 +28723,7 @@
                 <a:ea typeface="Calibri" pitchFamily="34" charset="-122"/>
                 <a:cs typeface="Calibri" pitchFamily="34" charset="-120"/>
               </a:rPr>
-              <a:t>Everyone: activate the venv, jupyter lab, open lab0-first-contact.ipynb, run the preflight() cell</a:t>
+              <a:t>Everyone: activate the venv, jupyter lab, open lab0-first-contact.ipynb, run preflight(), the model-list cell, and the tool-call cell</a:t>
             </a:r>
             <a:endParaRPr lang="en-US" sz="1500" dirty="0"/>
           </a:p>
@@ -28737,7 +28737,7 @@
         </p:nvSpPr>
         <p:spPr>
           <a:xfrm>
-            <a:off x="987552" y="3731133"/>
+            <a:off x="987552" y="3475863"/>
             <a:ext cx="457200" cy="328422"/>
           </a:xfrm>
           <a:prstGeom prst="rect">
@@ -28776,8 +28776,8 @@
         </p:nvSpPr>
         <p:spPr>
           <a:xfrm>
-            <a:off x="1499616" y="3731133"/>
-            <a:ext cx="4271620" cy="620268"/>
+            <a:off x="1499616" y="3475863"/>
+            <a:ext cx="4271620" cy="875538"/>
           </a:xfrm>
           <a:prstGeom prst="rect">
             <a:avLst/>
@@ -28801,7 +28801,7 @@
                 <a:ea typeface="Calibri" pitchFamily="34" charset="-122"/>
                 <a:cs typeface="Calibri" pitchFamily="34" charset="-120"/>
               </a:rPr>
-              <a:t>It prints what your machine can reach — hosted model, local model, key present or missing</a:t>
+              <a:t>preflight() prints what your machine can reach — hosted model, local model, key present or missing</a:t>
             </a:r>
             <a:endParaRPr lang="en-US" sz="1500" dirty="0"/>
           </a:p>
@@ -28855,7 +28855,7 @@
         <p:spPr>
           <a:xfrm>
             <a:off x="1499616" y="4607433"/>
-            <a:ext cx="4271620" cy="620268"/>
+            <a:ext cx="4271620" cy="875538"/>
           </a:xfrm>
           <a:prstGeom prst="rect">
             <a:avLst/>
@@ -28879,7 +28879,7 @@
                 <a:ea typeface="Calibri" pitchFamily="34" charset="-122"/>
                 <a:cs typeface="Calibri" pitchFamily="34" charset="-120"/>
               </a:rPr>
-              <a:t>Green on the hosted call is all you need. Ollama is optional and only used for comparison</a:t>
+              <a:t>The tool-call cell is the one that matters for later: catalog listing "tools" is not the same as emitting a well-formed call</a:t>
             </a:r>
             <a:endParaRPr lang="en-US" sz="1500" dirty="0"/>
           </a:p>
@@ -28915,7 +28915,7 @@
         </p:nvSpPr>
         <p:spPr>
           <a:xfrm>
-            <a:off x="6630772" y="2599563"/>
+            <a:off x="6630772" y="2344293"/>
             <a:ext cx="457200" cy="328422"/>
           </a:xfrm>
           <a:prstGeom prst="rect">
@@ -28954,7 +28954,7 @@
         </p:nvSpPr>
         <p:spPr>
           <a:xfrm>
-            <a:off x="7142836" y="2599563"/>
+            <a:off x="7142836" y="2344293"/>
             <a:ext cx="4271620" cy="875538"/>
           </a:xfrm>
           <a:prstGeom prst="rect">
@@ -28979,6 +28979,84 @@
                 <a:ea typeface="Calibri" pitchFamily="34" charset="-122"/>
                 <a:cs typeface="Calibri" pitchFamily="34" charset="-120"/>
               </a:rPr>
+              <a:t>Green on the hosted call plus TOOL CALL OK is all you need. Ollama is optional and only used for comparison</a:t>
+            </a:r>
+            <a:endParaRPr lang="en-US" sz="1500" dirty="0"/>
+          </a:p>
+        </p:txBody>
+      </p:sp>
+      <p:sp>
+        <p:nvSpPr>
+          <p:cNvPr id="15" name="Text 13"/>
+          <p:cNvSpPr txBox="1"/>
+          <p:nvPr/>
+        </p:nvSpPr>
+        <p:spPr>
+          <a:xfrm>
+            <a:off x="6630772" y="3475863"/>
+            <a:ext cx="457200" cy="328422"/>
+          </a:xfrm>
+          <a:prstGeom prst="rect">
+            <a:avLst/>
+          </a:prstGeom>
+          <a:noFill/>
+          <a:ln/>
+        </p:spPr>
+        <p:txBody>
+          <a:bodyPr wrap="square" lIns="0" tIns="0" rIns="0" bIns="0" rtlCol="0" anchor="t"/>
+          <a:lstStyle/>
+          <a:p>
+            <a:pPr indent="0" marL="0">
+              <a:buNone/>
+            </a:pPr>
+            <a:r>
+              <a:rPr lang="en-US" sz="1450" b="1" dirty="0">
+                <a:solidFill>
+                  <a:srgbClr val="17877C"/>
+                </a:solidFill>
+                <a:latin typeface="Calibri" pitchFamily="34" charset="0"/>
+                <a:ea typeface="Calibri" pitchFamily="34" charset="-122"/>
+                <a:cs typeface="Calibri" pitchFamily="34" charset="-120"/>
+              </a:rPr>
+              <a:t>05</a:t>
+            </a:r>
+            <a:endParaRPr lang="en-US" sz="1450" dirty="0"/>
+          </a:p>
+        </p:txBody>
+      </p:sp>
+      <p:sp>
+        <p:nvSpPr>
+          <p:cNvPr id="16" name="Text 14"/>
+          <p:cNvSpPr txBox="1"/>
+          <p:nvPr/>
+        </p:nvSpPr>
+        <p:spPr>
+          <a:xfrm>
+            <a:off x="7142836" y="3475863"/>
+            <a:ext cx="4271620" cy="875538"/>
+          </a:xfrm>
+          <a:prstGeom prst="rect">
+            <a:avLst/>
+          </a:prstGeom>
+          <a:noFill/>
+          <a:ln/>
+        </p:spPr>
+        <p:txBody>
+          <a:bodyPr wrap="square" lIns="0" tIns="0" rIns="0" bIns="0" rtlCol="0" anchor="t"/>
+          <a:lstStyle/>
+          <a:p>
+            <a:pPr indent="0" marL="0">
+              <a:buNone/>
+            </a:pPr>
+            <a:r>
+              <a:rPr lang="en-US" sz="1500" dirty="0">
+                <a:solidFill>
+                  <a:srgbClr val="3A464E"/>
+                </a:solidFill>
+                <a:latin typeface="Calibri" pitchFamily="34" charset="0"/>
+                <a:ea typeface="Calibri" pitchFamily="34" charset="-122"/>
+                <a:cs typeface="Calibri" pitchFamily="34" charset="-120"/>
+              </a:rPr>
               <a:t>If yours fails: the README troubleshooting table covers every failure we have seen. Pair up with someone whose works and keep moving</a:t>
             </a:r>
             <a:endParaRPr lang="en-US" sz="1500" dirty="0"/>
@@ -28987,13 +29065,13 @@
       </p:sp>
       <p:sp>
         <p:nvSpPr>
-          <p:cNvPr id="15" name="Text 13"/>
-          <p:cNvSpPr txBox="1"/>
-          <p:nvPr/>
-        </p:nvSpPr>
-        <p:spPr>
-          <a:xfrm>
-            <a:off x="6630772" y="3731133"/>
+          <p:cNvPr id="17" name="Text 15"/>
+          <p:cNvSpPr txBox="1"/>
+          <p:nvPr/>
+        </p:nvSpPr>
+        <p:spPr>
+          <a:xfrm>
+            <a:off x="6630772" y="4607433"/>
             <a:ext cx="457200" cy="328422"/>
           </a:xfrm>
           <a:prstGeom prst="rect">
@@ -29012,13 +29090,13 @@
             <a:r>
               <a:rPr lang="en-US" sz="1450" b="1" dirty="0">
                 <a:solidFill>
-                  <a:srgbClr val="17877C"/>
-                </a:solidFill>
-                <a:latin typeface="Calibri" pitchFamily="34" charset="0"/>
-                <a:ea typeface="Calibri" pitchFamily="34" charset="-122"/>
-                <a:cs typeface="Calibri" pitchFamily="34" charset="-120"/>
-              </a:rPr>
-              <a:t>05</a:t>
+                  <a:srgbClr val="E4572E"/>
+                </a:solidFill>
+                <a:latin typeface="Calibri" pitchFamily="34" charset="0"/>
+                <a:ea typeface="Calibri" pitchFamily="34" charset="-122"/>
+                <a:cs typeface="Calibri" pitchFamily="34" charset="-120"/>
+              </a:rPr>
+              <a:t>06</a:t>
             </a:r>
             <a:endParaRPr lang="en-US" sz="1450" dirty="0"/>
           </a:p>
@@ -29026,13 +29104,13 @@
       </p:sp>
       <p:sp>
         <p:nvSpPr>
-          <p:cNvPr id="16" name="Text 14"/>
-          <p:cNvSpPr txBox="1"/>
-          <p:nvPr/>
-        </p:nvSpPr>
-        <p:spPr>
-          <a:xfrm>
-            <a:off x="7142836" y="3731133"/>
+          <p:cNvPr id="18" name="Text 16"/>
+          <p:cNvSpPr txBox="1"/>
+          <p:nvPr/>
+        </p:nvSpPr>
+        <p:spPr>
+          <a:xfrm>
+            <a:off x="7142836" y="4607433"/>
             <a:ext cx="4271620" cy="620268"/>
           </a:xfrm>
           <a:prstGeom prst="rect">

</xml_diff>

<commit_message>
docs: add Module 7 gotchas and router slides
Bugs in the model, agent, and router look the same until you
name the layer. The clinic and Lab 0 slides make that triage
explicit before people spend a week on the prompt.

Co-authored-by: Cursor <cursoragent@cursor.com>
</commit_message>
<xml_diff>
--- a/presentation/ai-handson-lab.pptx
+++ b/presentation/ai-handson-lab.pptx
@@ -12,6 +12,7 @@
     <p:sldId id="260" r:id="rId6"/>
     <p:sldId id="261" r:id="rId7"/>
     <p:sldId id="262" r:id="rId8"/>
+    <p:sldId id="300" r:id="rId51"/>
     <p:sldId id="263" r:id="rId9"/>
     <p:sldId id="264" r:id="rId10"/>
     <p:sldId id="265" r:id="rId11"/>
@@ -29,6 +30,7 @@
     <p:sldId id="277" r:id="rId23"/>
     <p:sldId id="278" r:id="rId24"/>
     <p:sldId id="279" r:id="rId25"/>
+    <p:sldId id="301" r:id="rId52"/>
     <p:sldId id="280" r:id="rId26"/>
     <p:sldId id="281" r:id="rId27"/>
     <p:sldId id="282" r:id="rId28"/>
@@ -3924,6 +3926,146 @@
         <p14:creationId xmlns:p14="http://schemas.microsoft.com/office/powerpoint/2010/main" val="1024086991"/>
       </p:ext>
     </p:extLst>
+  </p:cSld>
+  <p:clrMapOvr>
+    <a:masterClrMapping/>
+  </p:clrMapOvr>
+</p:notes>
+</file>
+
+<file path=ppt/notesSlides/notesSlide45.xml><?xml version="1.0" encoding="utf-8"?>
+<p:notes xmlns:a="http://schemas.openxmlformats.org/drawingml/2006/main" xmlns:p="http://schemas.openxmlformats.org/presentationml/2006/main" xmlns:r="http://schemas.openxmlformats.org/officeDocument/2006/relationships">
+  <p:cSld>
+    <p:spTree>
+      <p:nvGrpSpPr>
+        <p:cNvPr id="1" name=""/>
+        <p:cNvGrpSpPr/>
+        <p:nvPr/>
+      </p:nvGrpSpPr>
+      <p:grpSpPr>
+        <a:xfrm>
+          <a:off x="0" y="0"/>
+          <a:ext cx="0" cy="0"/>
+          <a:chOff x="0" y="0"/>
+          <a:chExt cx="0" cy="0"/>
+        </a:xfrm>
+      </p:grpSpPr>
+      <p:sp>
+        <p:nvSpPr>
+          <p:cNvPr id="2" name="Slide Image Placeholder 1"/>
+          <p:cNvSpPr>
+            <a:spLocks noGrp="1"/>
+          </p:cNvSpPr>
+          <p:nvPr>
+            <p:ph type="sldImg" idx="2"/>
+          </p:nvPr>
+        </p:nvSpPr>
+        <p:spPr/>
+      </p:sp>
+      <p:sp>
+        <p:nvSpPr>
+          <p:cNvPr id="3" name="Notes Placeholder 2"/>
+          <p:cNvSpPr>
+            <a:spLocks noGrp="1"/>
+          </p:cNvSpPr>
+          <p:nvPr>
+            <p:ph type="body" idx="3" sz="quarter"/>
+          </p:nvPr>
+        </p:nvSpPr>
+        <p:spPr/>
+        <p:txBody>
+          <a:bodyPr/>
+          <a:lstStyle/>
+          <a:p>
+            <a:r>
+              <a:t>This is the layer nobody teaches and everybody runs. Say out loud that Bedrock, Vertex, LiteLLM and any internal model-picker behave the same way. It takes thirty seconds and saves someone a week later in the year.</a:t>
+            </a:r>
+          </a:p>
+        </p:txBody>
+      </p:sp>
+      <p:sp>
+        <p:nvSpPr>
+          <p:cNvPr id="4" name="Slide Number Placeholder 3"/>
+          <p:cNvSpPr>
+            <a:spLocks noGrp="1"/>
+          </p:cNvSpPr>
+          <p:nvPr>
+            <p:ph type="sldNum" idx="5" sz="quarter"/>
+          </p:nvPr>
+        </p:nvSpPr>
+        <p:spPr/>
+      </p:sp>
+    </p:spTree>
+  </p:cSld>
+  <p:clrMapOvr>
+    <a:masterClrMapping/>
+  </p:clrMapOvr>
+</p:notes>
+</file>
+
+<file path=ppt/notesSlides/notesSlide46.xml><?xml version="1.0" encoding="utf-8"?>
+<p:notes xmlns:a="http://schemas.openxmlformats.org/drawingml/2006/main" xmlns:p="http://schemas.openxmlformats.org/presentationml/2006/main" xmlns:r="http://schemas.openxmlformats.org/officeDocument/2006/relationships">
+  <p:cSld>
+    <p:spTree>
+      <p:nvGrpSpPr>
+        <p:cNvPr id="1" name=""/>
+        <p:cNvGrpSpPr/>
+        <p:nvPr/>
+      </p:nvGrpSpPr>
+      <p:grpSpPr>
+        <a:xfrm>
+          <a:off x="0" y="0"/>
+          <a:ext cx="0" cy="0"/>
+          <a:chOff x="0" y="0"/>
+          <a:chExt cx="0" cy="0"/>
+        </a:xfrm>
+      </p:grpSpPr>
+      <p:sp>
+        <p:nvSpPr>
+          <p:cNvPr id="2" name="Slide Image Placeholder 1"/>
+          <p:cNvSpPr>
+            <a:spLocks noGrp="1"/>
+          </p:cNvSpPr>
+          <p:nvPr>
+            <p:ph type="sldImg" idx="2"/>
+          </p:nvPr>
+        </p:nvSpPr>
+        <p:spPr/>
+      </p:sp>
+      <p:sp>
+        <p:nvSpPr>
+          <p:cNvPr id="3" name="Notes Placeholder 2"/>
+          <p:cNvSpPr>
+            <a:spLocks noGrp="1"/>
+          </p:cNvSpPr>
+          <p:nvPr>
+            <p:ph type="body" idx="3" sz="quarter"/>
+          </p:nvPr>
+        </p:nvSpPr>
+        <p:spPr/>
+        <p:txBody>
+          <a:bodyPr/>
+          <a:lstStyle/>
+          <a:p>
+            <a:r>
+              <a:t>Map each of these to a layer out loud: quota and provider swap are the router, malformed tool calls are the model, the loop that keeps retrying is your code. That triage habit is worth more than any single fix on this slide.</a:t>
+            </a:r>
+          </a:p>
+        </p:txBody>
+      </p:sp>
+      <p:sp>
+        <p:nvSpPr>
+          <p:cNvPr id="4" name="Slide Number Placeholder 3"/>
+          <p:cNvSpPr>
+            <a:spLocks noGrp="1"/>
+          </p:cNvSpPr>
+          <p:nvPr>
+            <p:ph type="sldNum" idx="5" sz="quarter"/>
+          </p:nvPr>
+        </p:nvSpPr>
+        <p:spPr/>
+      </p:sp>
+    </p:spTree>
   </p:cSld>
   <p:clrMapOvr>
     <a:masterClrMapping/>
@@ -5025,7 +5167,7 @@
                 <a:ea typeface="Calibri" pitchFamily="34" charset="-122"/>
                 <a:cs typeface="Calibri" pitchFamily="34" charset="-120"/>
               </a:rPr>
-              <a:t>10</a:t>
+              <a:t>11</a:t>
             </a:r>
             <a:endParaRPr lang="en-US" sz="950" dirty="0"/>
           </a:p>
@@ -5494,7 +5636,7 @@
                 <a:ea typeface="Calibri" pitchFamily="34" charset="-122"/>
                 <a:cs typeface="Calibri" pitchFamily="34" charset="-120"/>
               </a:rPr>
-              <a:t>11</a:t>
+              <a:t>12</a:t>
             </a:r>
             <a:endParaRPr lang="en-US" sz="950" dirty="0"/>
           </a:p>
@@ -6165,7 +6307,7 @@
                 <a:ea typeface="Calibri" pitchFamily="34" charset="-122"/>
                 <a:cs typeface="Calibri" pitchFamily="34" charset="-120"/>
               </a:rPr>
-              <a:t>12</a:t>
+              <a:t>13</a:t>
             </a:r>
             <a:endParaRPr lang="en-US" sz="950" dirty="0"/>
           </a:p>
@@ -6659,7 +6801,7 @@
                 <a:ea typeface="Calibri" pitchFamily="34" charset="-122"/>
                 <a:cs typeface="Calibri" pitchFamily="34" charset="-120"/>
               </a:rPr>
-              <a:t>13</a:t>
+              <a:t>14</a:t>
             </a:r>
             <a:endParaRPr lang="en-US" sz="950" dirty="0"/>
           </a:p>
@@ -7478,7 +7620,7 @@
                 <a:ea typeface="Calibri" pitchFamily="34" charset="-122"/>
                 <a:cs typeface="Calibri" pitchFamily="34" charset="-120"/>
               </a:rPr>
-              <a:t>14</a:t>
+              <a:t>15</a:t>
             </a:r>
             <a:endParaRPr lang="en-US" sz="950" dirty="0"/>
           </a:p>
@@ -8221,7 +8363,7 @@
                 <a:ea typeface="Calibri" pitchFamily="34" charset="-122"/>
                 <a:cs typeface="Calibri" pitchFamily="34" charset="-120"/>
               </a:rPr>
-              <a:t>15</a:t>
+              <a:t>16</a:t>
             </a:r>
             <a:endParaRPr lang="en-US" sz="950" dirty="0"/>
           </a:p>
@@ -8331,7 +8473,7 @@
                 <a:ea typeface="Calibri" pitchFamily="34" charset="-122"/>
                 <a:cs typeface="Calibri" pitchFamily="34" charset="-120"/>
               </a:rPr>
-              <a:t>16</a:t>
+              <a:t>17</a:t>
             </a:r>
             <a:endParaRPr lang="en-US" sz="950" dirty="0"/>
           </a:p>
@@ -8800,7 +8942,7 @@
                 <a:ea typeface="Calibri" pitchFamily="34" charset="-122"/>
                 <a:cs typeface="Calibri" pitchFamily="34" charset="-120"/>
               </a:rPr>
-              <a:t>17</a:t>
+              <a:t>18</a:t>
             </a:r>
             <a:endParaRPr lang="en-US" sz="950" dirty="0"/>
           </a:p>
@@ -9266,7 +9408,7 @@
                 <a:ea typeface="Calibri" pitchFamily="34" charset="-122"/>
                 <a:cs typeface="Calibri" pitchFamily="34" charset="-120"/>
               </a:rPr>
-              <a:t>18</a:t>
+              <a:t>19</a:t>
             </a:r>
             <a:endParaRPr lang="en-US" sz="950" dirty="0"/>
           </a:p>
@@ -10330,7 +10472,7 @@
                 <a:ea typeface="Calibri" pitchFamily="34" charset="-122"/>
                 <a:cs typeface="Calibri" pitchFamily="34" charset="-120"/>
               </a:rPr>
-              <a:t>19</a:t>
+              <a:t>20</a:t>
             </a:r>
             <a:endParaRPr lang="en-US" sz="950" dirty="0"/>
           </a:p>
@@ -11938,7 +12080,7 @@
                 <a:ea typeface="Calibri" pitchFamily="34" charset="-122"/>
                 <a:cs typeface="Calibri" pitchFamily="34" charset="-120"/>
               </a:rPr>
-              <a:t>20</a:t>
+              <a:t>21</a:t>
             </a:r>
             <a:endParaRPr lang="en-US" sz="950" dirty="0"/>
           </a:p>
@@ -12549,7 +12691,7 @@
                 <a:ea typeface="Calibri" pitchFamily="34" charset="-122"/>
                 <a:cs typeface="Calibri" pitchFamily="34" charset="-120"/>
               </a:rPr>
-              <a:t>21</a:t>
+              <a:t>22</a:t>
             </a:r>
             <a:endParaRPr lang="en-US" sz="950" dirty="0"/>
           </a:p>
@@ -13103,7 +13245,7 @@
                 <a:ea typeface="Calibri" pitchFamily="34" charset="-122"/>
                 <a:cs typeface="Calibri" pitchFamily="34" charset="-120"/>
               </a:rPr>
-              <a:t>22</a:t>
+              <a:t>23</a:t>
             </a:r>
             <a:endParaRPr lang="en-US" sz="950" dirty="0"/>
           </a:p>
@@ -13572,7 +13714,7 @@
                 <a:ea typeface="Calibri" pitchFamily="34" charset="-122"/>
                 <a:cs typeface="Calibri" pitchFamily="34" charset="-120"/>
               </a:rPr>
-              <a:t>23</a:t>
+              <a:t>24</a:t>
             </a:r>
             <a:endParaRPr lang="en-US" sz="950" dirty="0"/>
           </a:p>
@@ -14564,7 +14706,7 @@
                 <a:ea typeface="Calibri" pitchFamily="34" charset="-122"/>
                 <a:cs typeface="Calibri" pitchFamily="34" charset="-120"/>
               </a:rPr>
-              <a:t>24</a:t>
+              <a:t>25</a:t>
             </a:r>
             <a:endParaRPr lang="en-US" sz="950" dirty="0"/>
           </a:p>
@@ -15030,7 +15172,7 @@
                 <a:ea typeface="Calibri" pitchFamily="34" charset="-122"/>
                 <a:cs typeface="Calibri" pitchFamily="34" charset="-120"/>
               </a:rPr>
-              <a:t>25</a:t>
+              <a:t>27</a:t>
             </a:r>
             <a:endParaRPr lang="en-US" sz="950" dirty="0"/>
           </a:p>
@@ -15773,7 +15915,7 @@
                 <a:ea typeface="Calibri" pitchFamily="34" charset="-122"/>
                 <a:cs typeface="Calibri" pitchFamily="34" charset="-120"/>
               </a:rPr>
-              <a:t>26</a:t>
+              <a:t>28</a:t>
             </a:r>
             <a:endParaRPr lang="en-US" sz="950" dirty="0"/>
           </a:p>
@@ -15883,7 +16025,7 @@
                 <a:ea typeface="Calibri" pitchFamily="34" charset="-122"/>
                 <a:cs typeface="Calibri" pitchFamily="34" charset="-120"/>
               </a:rPr>
-              <a:t>27</a:t>
+              <a:t>29</a:t>
             </a:r>
             <a:endParaRPr lang="en-US" sz="950" dirty="0"/>
           </a:p>
@@ -16352,7 +16494,7 @@
                 <a:ea typeface="Calibri" pitchFamily="34" charset="-122"/>
                 <a:cs typeface="Calibri" pitchFamily="34" charset="-120"/>
               </a:rPr>
-              <a:t>28</a:t>
+              <a:t>30</a:t>
             </a:r>
             <a:endParaRPr lang="en-US" sz="950" dirty="0"/>
           </a:p>
@@ -16832,7 +16974,7 @@
                 <a:ea typeface="Calibri" pitchFamily="34" charset="-122"/>
                 <a:cs typeface="Calibri" pitchFamily="34" charset="-120"/>
               </a:rPr>
-              <a:t>29</a:t>
+              <a:t>31</a:t>
             </a:r>
             <a:endParaRPr lang="en-US" sz="950" dirty="0"/>
           </a:p>
@@ -18334,7 +18476,7 @@
                 <a:ea typeface="Calibri" pitchFamily="34" charset="-122"/>
                 <a:cs typeface="Calibri" pitchFamily="34" charset="-120"/>
               </a:rPr>
-              <a:t>30</a:t>
+              <a:t>32</a:t>
             </a:r>
             <a:endParaRPr lang="en-US" sz="950" dirty="0"/>
           </a:p>
@@ -18917,7 +19059,7 @@
                 <a:ea typeface="Calibri" pitchFamily="34" charset="-122"/>
                 <a:cs typeface="Calibri" pitchFamily="34" charset="-120"/>
               </a:rPr>
-              <a:t>31</a:t>
+              <a:t>33</a:t>
             </a:r>
             <a:endParaRPr lang="en-US" sz="950" dirty="0"/>
           </a:p>
@@ -19386,7 +19528,7 @@
                 <a:ea typeface="Calibri" pitchFamily="34" charset="-122"/>
                 <a:cs typeface="Calibri" pitchFamily="34" charset="-120"/>
               </a:rPr>
-              <a:t>32</a:t>
+              <a:t>34</a:t>
             </a:r>
             <a:endParaRPr lang="en-US" sz="950" dirty="0"/>
           </a:p>
@@ -20012,7 +20154,7 @@
                 <a:ea typeface="Calibri" pitchFamily="34" charset="-122"/>
                 <a:cs typeface="Calibri" pitchFamily="34" charset="-120"/>
               </a:rPr>
-              <a:t>33</a:t>
+              <a:t>35</a:t>
             </a:r>
             <a:endParaRPr lang="en-US" sz="950" dirty="0"/>
           </a:p>
@@ -20122,7 +20264,7 @@
                 <a:ea typeface="Calibri" pitchFamily="34" charset="-122"/>
                 <a:cs typeface="Calibri" pitchFamily="34" charset="-120"/>
               </a:rPr>
-              <a:t>34</a:t>
+              <a:t>36</a:t>
             </a:r>
             <a:endParaRPr lang="en-US" sz="950" dirty="0"/>
           </a:p>
@@ -20705,7 +20847,7 @@
                 <a:ea typeface="Calibri" pitchFamily="34" charset="-122"/>
                 <a:cs typeface="Calibri" pitchFamily="34" charset="-120"/>
               </a:rPr>
-              <a:t>35</a:t>
+              <a:t>37</a:t>
             </a:r>
             <a:endParaRPr lang="en-US" sz="950" dirty="0"/>
           </a:p>
@@ -21510,7 +21652,7 @@
                 <a:ea typeface="Calibri" pitchFamily="34" charset="-122"/>
                 <a:cs typeface="Calibri" pitchFamily="34" charset="-120"/>
               </a:rPr>
-              <a:t>36</a:t>
+              <a:t>38</a:t>
             </a:r>
             <a:endParaRPr lang="en-US" sz="950" dirty="0"/>
           </a:p>
@@ -22621,7 +22763,7 @@
                 <a:ea typeface="Calibri" pitchFamily="34" charset="-122"/>
                 <a:cs typeface="Calibri" pitchFamily="34" charset="-120"/>
               </a:rPr>
-              <a:t>37</a:t>
+              <a:t>39</a:t>
             </a:r>
             <a:endParaRPr lang="en-US" sz="950" dirty="0"/>
           </a:p>
@@ -23090,7 +23232,7 @@
                 <a:ea typeface="Calibri" pitchFamily="34" charset="-122"/>
                 <a:cs typeface="Calibri" pitchFamily="34" charset="-120"/>
               </a:rPr>
-              <a:t>38</a:t>
+              <a:t>40</a:t>
             </a:r>
             <a:endParaRPr lang="en-US" sz="950" dirty="0"/>
           </a:p>
@@ -23556,7 +23698,7 @@
                 <a:ea typeface="Calibri" pitchFamily="34" charset="-122"/>
                 <a:cs typeface="Calibri" pitchFamily="34" charset="-120"/>
               </a:rPr>
-              <a:t>39</a:t>
+              <a:t>41</a:t>
             </a:r>
             <a:endParaRPr lang="en-US" sz="950" dirty="0"/>
           </a:p>
@@ -24605,7 +24747,7 @@
                 <a:ea typeface="Calibri" pitchFamily="34" charset="-122"/>
                 <a:cs typeface="Calibri" pitchFamily="34" charset="-120"/>
               </a:rPr>
-              <a:t>40</a:t>
+              <a:t>42</a:t>
             </a:r>
             <a:endParaRPr lang="en-US" sz="950" dirty="0"/>
           </a:p>
@@ -25727,7 +25869,7 @@
                 <a:ea typeface="Calibri" pitchFamily="34" charset="-122"/>
                 <a:cs typeface="Calibri" pitchFamily="34" charset="-120"/>
               </a:rPr>
-              <a:t>41</a:t>
+              <a:t>43</a:t>
             </a:r>
             <a:endParaRPr lang="en-US" sz="950" dirty="0"/>
           </a:p>
@@ -26196,7 +26338,7 @@
                 <a:ea typeface="Calibri" pitchFamily="34" charset="-122"/>
                 <a:cs typeface="Calibri" pitchFamily="34" charset="-120"/>
               </a:rPr>
-              <a:t>42</a:t>
+              <a:t>44</a:t>
             </a:r>
             <a:endParaRPr lang="en-US" sz="950" dirty="0"/>
           </a:p>
@@ -26690,7 +26832,7 @@
                 <a:ea typeface="Calibri" pitchFamily="34" charset="-122"/>
                 <a:cs typeface="Calibri" pitchFamily="34" charset="-120"/>
               </a:rPr>
-              <a:t>43</a:t>
+              <a:t>45</a:t>
             </a:r>
             <a:endParaRPr lang="en-US" sz="950" dirty="0"/>
           </a:p>
@@ -27385,6 +27527,1517 @@
 </p:sld>
 </file>
 
+<file path=ppt/slides/slide45.xml><?xml version="1.0" encoding="utf-8"?>
+<p:sld xmlns:a="http://schemas.openxmlformats.org/drawingml/2006/main" xmlns:p="http://schemas.openxmlformats.org/presentationml/2006/main" xmlns:r="http://schemas.openxmlformats.org/officeDocument/2006/relationships">
+  <p:cSld>
+    <p:spTree>
+      <p:nvGrpSpPr>
+        <p:cNvPr id="1" name=""/>
+        <p:cNvGrpSpPr/>
+        <p:nvPr/>
+      </p:nvGrpSpPr>
+      <p:grpSpPr/>
+      <p:sp>
+        <p:nvSpPr>
+          <p:cNvPr id="2" name="TextBox 1"/>
+          <p:cNvSpPr txBox="1"/>
+          <p:nvPr/>
+        </p:nvSpPr>
+        <p:spPr>
+          <a:xfrm>
+            <a:off x="658368" y="347472"/>
+            <a:ext cx="9601200" cy="237744"/>
+          </a:xfrm>
+          <a:prstGeom prst="rect">
+            <a:avLst/>
+          </a:prstGeom>
+          <a:noFill/>
+        </p:spPr>
+        <p:txBody>
+          <a:bodyPr wrap="square" lIns="0" rIns="0" tIns="0" bIns="0" anchor="ctr">
+            <a:spAutoFit/>
+          </a:bodyPr>
+          <a:lstStyle/>
+          <a:p>
+            <a:r>
+              <a:rPr sz="1000" b="1" spc="160">
+                <a:solidFill>
+                  <a:srgbClr val="E4572E"/>
+                </a:solidFill>
+                <a:latin typeface="Calibri"/>
+              </a:rPr>
+              <a:t>BLOCK 1 · WARM-UP: FIRST CALLS AND BROCHURES</a:t>
+            </a:r>
+          </a:p>
+        </p:txBody>
+      </p:sp>
+      <p:sp>
+        <p:nvSpPr>
+          <p:cNvPr id="3" name="TextBox 2"/>
+          <p:cNvSpPr txBox="1"/>
+          <p:nvPr/>
+        </p:nvSpPr>
+        <p:spPr>
+          <a:xfrm>
+            <a:off x="658368" y="694944"/>
+            <a:ext cx="10872216" cy="786384"/>
+          </a:xfrm>
+          <a:prstGeom prst="rect">
+            <a:avLst/>
+          </a:prstGeom>
+          <a:noFill/>
+        </p:spPr>
+        <p:txBody>
+          <a:bodyPr wrap="square" lIns="0" rIns="0" tIns="0" bIns="0" anchor="ctr">
+            <a:spAutoFit/>
+          </a:bodyPr>
+          <a:lstStyle/>
+          <a:p>
+            <a:r>
+              <a:rPr sz="3300" b="1">
+                <a:solidFill>
+                  <a:srgbClr val="1B2227"/>
+                </a:solidFill>
+                <a:latin typeface="Cambria"/>
+              </a:rPr>
+              <a:t>The router is a layer, not a URL</a:t>
+            </a:r>
+          </a:p>
+        </p:txBody>
+      </p:sp>
+      <p:sp>
+        <p:nvSpPr>
+          <p:cNvPr id="4" name="Rounded Rectangle 3"/>
+          <p:cNvSpPr/>
+          <p:nvPr/>
+        </p:nvSpPr>
+        <p:spPr>
+          <a:xfrm>
+            <a:off x="658368" y="1572768"/>
+            <a:ext cx="10872216" cy="4553712"/>
+          </a:xfrm>
+          <a:prstGeom prst="roundRect">
+            <a:avLst>
+              <a:gd name="adj" fmla="val 1200"/>
+            </a:avLst>
+          </a:prstGeom>
+          <a:solidFill>
+            <a:srgbClr val="F3F5F6"/>
+          </a:solidFill>
+          <a:ln>
+            <a:noFill/>
+          </a:ln>
+          <a:effectLst/>
+        </p:spPr>
+        <p:style>
+          <a:lnRef idx="1">
+            <a:schemeClr val="accent1"/>
+          </a:lnRef>
+          <a:fillRef idx="3">
+            <a:schemeClr val="accent1"/>
+          </a:fillRef>
+          <a:effectRef idx="2">
+            <a:schemeClr val="accent1"/>
+          </a:effectRef>
+          <a:fontRef idx="minor">
+            <a:schemeClr val="lt1"/>
+          </a:fontRef>
+        </p:style>
+        <p:txBody>
+          <a:bodyPr rtlCol="0" anchor="ctr"/>
+          <a:lstStyle/>
+          <a:p>
+            <a:pPr algn="ctr"/>
+          </a:p>
+        </p:txBody>
+      </p:sp>
+      <p:sp>
+        <p:nvSpPr>
+          <p:cNvPr id="5" name="Oval 4"/>
+          <p:cNvSpPr/>
+          <p:nvPr/>
+        </p:nvSpPr>
+        <p:spPr>
+          <a:xfrm>
+            <a:off x="1042415" y="2008936"/>
+            <a:ext cx="146304" cy="146304"/>
+          </a:xfrm>
+          <a:prstGeom prst="ellipse">
+            <a:avLst/>
+          </a:prstGeom>
+          <a:solidFill>
+            <a:srgbClr val="E4572E"/>
+          </a:solidFill>
+          <a:ln>
+            <a:noFill/>
+          </a:ln>
+          <a:effectLst/>
+        </p:spPr>
+        <p:style>
+          <a:lnRef idx="1">
+            <a:schemeClr val="accent1"/>
+          </a:lnRef>
+          <a:fillRef idx="3">
+            <a:schemeClr val="accent1"/>
+          </a:fillRef>
+          <a:effectRef idx="2">
+            <a:schemeClr val="accent1"/>
+          </a:effectRef>
+          <a:fontRef idx="minor">
+            <a:schemeClr val="lt1"/>
+          </a:fontRef>
+        </p:style>
+        <p:txBody>
+          <a:bodyPr rtlCol="0" anchor="ctr"/>
+          <a:lstStyle/>
+          <a:p>
+            <a:pPr algn="ctr"/>
+          </a:p>
+        </p:txBody>
+      </p:sp>
+      <p:sp>
+        <p:nvSpPr>
+          <p:cNvPr id="6" name="TextBox 5"/>
+          <p:cNvSpPr txBox="1"/>
+          <p:nvPr/>
+        </p:nvSpPr>
+        <p:spPr>
+          <a:xfrm>
+            <a:off x="1371600" y="1956816"/>
+            <a:ext cx="9774936" cy="610819"/>
+          </a:xfrm>
+          <a:prstGeom prst="rect">
+            <a:avLst/>
+          </a:prstGeom>
+          <a:noFill/>
+        </p:spPr>
+        <p:txBody>
+          <a:bodyPr wrap="square" lIns="0" rIns="0" tIns="0" bIns="0" anchor="t">
+            <a:spAutoFit/>
+          </a:bodyPr>
+          <a:lstStyle/>
+          <a:p>
+            <a:r>
+              <a:rPr sz="1500" b="0">
+                <a:solidFill>
+                  <a:srgbClr val="3A464E"/>
+                </a:solidFill>
+                <a:latin typeface="Calibri"/>
+              </a:rPr>
+              <a:t>OpenRouter is not a model. It is a </a:t>
+            </a:r>
+            <a:r>
+              <a:rPr sz="1500" b="1">
+                <a:solidFill>
+                  <a:srgbClr val="1B2227"/>
+                </a:solidFill>
+                <a:latin typeface="Calibri"/>
+              </a:rPr>
+              <a:t>router</a:t>
+            </a:r>
+            <a:r>
+              <a:rPr sz="1500" b="0">
+                <a:solidFill>
+                  <a:srgbClr val="3A464E"/>
+                </a:solidFill>
+                <a:latin typeface="Calibri"/>
+              </a:rPr>
+              <a:t>: it picks a provider for the model id you asked for, and hides the failures of the one it picked</a:t>
+            </a:r>
+          </a:p>
+        </p:txBody>
+      </p:sp>
+      <p:sp>
+        <p:nvSpPr>
+          <p:cNvPr id="7" name="Oval 6"/>
+          <p:cNvSpPr/>
+          <p:nvPr/>
+        </p:nvSpPr>
+        <p:spPr>
+          <a:xfrm>
+            <a:off x="1042415" y="2867558"/>
+            <a:ext cx="146304" cy="146304"/>
+          </a:xfrm>
+          <a:prstGeom prst="ellipse">
+            <a:avLst/>
+          </a:prstGeom>
+          <a:solidFill>
+            <a:srgbClr val="17877C"/>
+          </a:solidFill>
+          <a:ln>
+            <a:noFill/>
+          </a:ln>
+          <a:effectLst/>
+        </p:spPr>
+        <p:style>
+          <a:lnRef idx="1">
+            <a:schemeClr val="accent1"/>
+          </a:lnRef>
+          <a:fillRef idx="3">
+            <a:schemeClr val="accent1"/>
+          </a:fillRef>
+          <a:effectRef idx="2">
+            <a:schemeClr val="accent1"/>
+          </a:effectRef>
+          <a:fontRef idx="minor">
+            <a:schemeClr val="lt1"/>
+          </a:fontRef>
+        </p:style>
+        <p:txBody>
+          <a:bodyPr rtlCol="0" anchor="ctr"/>
+          <a:lstStyle/>
+          <a:p>
+            <a:pPr algn="ctr"/>
+          </a:p>
+        </p:txBody>
+      </p:sp>
+      <p:sp>
+        <p:nvSpPr>
+          <p:cNvPr id="8" name="TextBox 7"/>
+          <p:cNvSpPr txBox="1"/>
+          <p:nvPr/>
+        </p:nvSpPr>
+        <p:spPr>
+          <a:xfrm>
+            <a:off x="1371600" y="2815437"/>
+            <a:ext cx="9774936" cy="610819"/>
+          </a:xfrm>
+          <a:prstGeom prst="rect">
+            <a:avLst/>
+          </a:prstGeom>
+          <a:noFill/>
+        </p:spPr>
+        <p:txBody>
+          <a:bodyPr wrap="square" lIns="0" rIns="0" tIns="0" bIns="0" anchor="t">
+            <a:spAutoFit/>
+          </a:bodyPr>
+          <a:lstStyle/>
+          <a:p>
+            <a:r>
+              <a:rPr sz="1500" b="0">
+                <a:solidFill>
+                  <a:srgbClr val="3A464E"/>
+                </a:solidFill>
+                <a:latin typeface="Calibri"/>
+              </a:rPr>
+              <a:t>The same model id can be served by several providers at different quantization, context length and speed — so the model name is not the unit of reproducibility</a:t>
+            </a:r>
+          </a:p>
+        </p:txBody>
+      </p:sp>
+      <p:sp>
+        <p:nvSpPr>
+          <p:cNvPr id="9" name="Oval 8"/>
+          <p:cNvSpPr/>
+          <p:nvPr/>
+        </p:nvSpPr>
+        <p:spPr>
+          <a:xfrm>
+            <a:off x="1042415" y="3726180"/>
+            <a:ext cx="146304" cy="146304"/>
+          </a:xfrm>
+          <a:prstGeom prst="ellipse">
+            <a:avLst/>
+          </a:prstGeom>
+          <a:solidFill>
+            <a:srgbClr val="E4572E"/>
+          </a:solidFill>
+          <a:ln>
+            <a:noFill/>
+          </a:ln>
+          <a:effectLst/>
+        </p:spPr>
+        <p:style>
+          <a:lnRef idx="1">
+            <a:schemeClr val="accent1"/>
+          </a:lnRef>
+          <a:fillRef idx="3">
+            <a:schemeClr val="accent1"/>
+          </a:fillRef>
+          <a:effectRef idx="2">
+            <a:schemeClr val="accent1"/>
+          </a:effectRef>
+          <a:fontRef idx="minor">
+            <a:schemeClr val="lt1"/>
+          </a:fontRef>
+        </p:style>
+        <p:txBody>
+          <a:bodyPr rtlCol="0" anchor="ctr"/>
+          <a:lstStyle/>
+          <a:p>
+            <a:pPr algn="ctr"/>
+          </a:p>
+        </p:txBody>
+      </p:sp>
+      <p:sp>
+        <p:nvSpPr>
+          <p:cNvPr id="10" name="TextBox 9"/>
+          <p:cNvSpPr txBox="1"/>
+          <p:nvPr/>
+        </p:nvSpPr>
+        <p:spPr>
+          <a:xfrm>
+            <a:off x="1371600" y="3674059"/>
+            <a:ext cx="9774936" cy="610819"/>
+          </a:xfrm>
+          <a:prstGeom prst="rect">
+            <a:avLst/>
+          </a:prstGeom>
+          <a:noFill/>
+        </p:spPr>
+        <p:txBody>
+          <a:bodyPr wrap="square" lIns="0" rIns="0" tIns="0" bIns="0" anchor="t">
+            <a:spAutoFit/>
+          </a:bodyPr>
+          <a:lstStyle/>
+          <a:p>
+            <a:r>
+              <a:rPr sz="1500" b="0">
+                <a:solidFill>
+                  <a:srgbClr val="3A464E"/>
+                </a:solidFill>
+                <a:latin typeface="Calibri"/>
+              </a:rPr>
+              <a:t>By default it falls back to another provider when one errors, and it accepts parameters a provider does not support and quietly ignores them</a:t>
+            </a:r>
+          </a:p>
+        </p:txBody>
+      </p:sp>
+      <p:sp>
+        <p:nvSpPr>
+          <p:cNvPr id="11" name="Oval 10"/>
+          <p:cNvSpPr/>
+          <p:nvPr/>
+        </p:nvSpPr>
+        <p:spPr>
+          <a:xfrm>
+            <a:off x="1042415" y="4584801"/>
+            <a:ext cx="146304" cy="146304"/>
+          </a:xfrm>
+          <a:prstGeom prst="ellipse">
+            <a:avLst/>
+          </a:prstGeom>
+          <a:solidFill>
+            <a:srgbClr val="17877C"/>
+          </a:solidFill>
+          <a:ln>
+            <a:noFill/>
+          </a:ln>
+          <a:effectLst/>
+        </p:spPr>
+        <p:style>
+          <a:lnRef idx="1">
+            <a:schemeClr val="accent1"/>
+          </a:lnRef>
+          <a:fillRef idx="3">
+            <a:schemeClr val="accent1"/>
+          </a:fillRef>
+          <a:effectRef idx="2">
+            <a:schemeClr val="accent1"/>
+          </a:effectRef>
+          <a:fontRef idx="minor">
+            <a:schemeClr val="lt1"/>
+          </a:fontRef>
+        </p:style>
+        <p:txBody>
+          <a:bodyPr rtlCol="0" anchor="ctr"/>
+          <a:lstStyle/>
+          <a:p>
+            <a:pPr algn="ctr"/>
+          </a:p>
+        </p:txBody>
+      </p:sp>
+      <p:sp>
+        <p:nvSpPr>
+          <p:cNvPr id="12" name="TextBox 11"/>
+          <p:cNvSpPr txBox="1"/>
+          <p:nvPr/>
+        </p:nvSpPr>
+        <p:spPr>
+          <a:xfrm>
+            <a:off x="1371600" y="4532680"/>
+            <a:ext cx="9774936" cy="610819"/>
+          </a:xfrm>
+          <a:prstGeom prst="rect">
+            <a:avLst/>
+          </a:prstGeom>
+          <a:noFill/>
+        </p:spPr>
+        <p:txBody>
+          <a:bodyPr wrap="square" lIns="0" rIns="0" tIns="0" bIns="0" anchor="t">
+            <a:spAutoFit/>
+          </a:bodyPr>
+          <a:lstStyle/>
+          <a:p>
+            <a:r>
+              <a:rPr sz="1500" b="0">
+                <a:solidFill>
+                  <a:srgbClr val="3A464E"/>
+                </a:solidFill>
+                <a:latin typeface="Calibri"/>
+              </a:rPr>
+              <a:t>That is excellent for a workshop and dangerous for a benchmark: two identical calls can be served by two different machines</a:t>
+            </a:r>
+          </a:p>
+        </p:txBody>
+      </p:sp>
+      <p:sp>
+        <p:nvSpPr>
+          <p:cNvPr id="13" name="Oval 12"/>
+          <p:cNvSpPr/>
+          <p:nvPr/>
+        </p:nvSpPr>
+        <p:spPr>
+          <a:xfrm>
+            <a:off x="1042415" y="5443423"/>
+            <a:ext cx="146304" cy="146304"/>
+          </a:xfrm>
+          <a:prstGeom prst="ellipse">
+            <a:avLst/>
+          </a:prstGeom>
+          <a:solidFill>
+            <a:srgbClr val="E4572E"/>
+          </a:solidFill>
+          <a:ln>
+            <a:noFill/>
+          </a:ln>
+          <a:effectLst/>
+        </p:spPr>
+        <p:style>
+          <a:lnRef idx="1">
+            <a:schemeClr val="accent1"/>
+          </a:lnRef>
+          <a:fillRef idx="3">
+            <a:schemeClr val="accent1"/>
+          </a:fillRef>
+          <a:effectRef idx="2">
+            <a:schemeClr val="accent1"/>
+          </a:effectRef>
+          <a:fontRef idx="minor">
+            <a:schemeClr val="lt1"/>
+          </a:fontRef>
+        </p:style>
+        <p:txBody>
+          <a:bodyPr rtlCol="0" anchor="ctr"/>
+          <a:lstStyle/>
+          <a:p>
+            <a:pPr algn="ctr"/>
+          </a:p>
+        </p:txBody>
+      </p:sp>
+      <p:sp>
+        <p:nvSpPr>
+          <p:cNvPr id="14" name="TextBox 13"/>
+          <p:cNvSpPr txBox="1"/>
+          <p:nvPr/>
+        </p:nvSpPr>
+        <p:spPr>
+          <a:xfrm>
+            <a:off x="1371600" y="5391302"/>
+            <a:ext cx="9774936" cy="351129"/>
+          </a:xfrm>
+          <a:prstGeom prst="rect">
+            <a:avLst/>
+          </a:prstGeom>
+          <a:noFill/>
+        </p:spPr>
+        <p:txBody>
+          <a:bodyPr wrap="square" lIns="0" rIns="0" tIns="0" bIns="0" anchor="t">
+            <a:spAutoFit/>
+          </a:bodyPr>
+          <a:lstStyle/>
+          <a:p>
+            <a:r>
+              <a:rPr sz="1500" b="0">
+                <a:solidFill>
+                  <a:srgbClr val="3A464E"/>
+                </a:solidFill>
+                <a:latin typeface="Calibri"/>
+              </a:rPr>
+              <a:t>Rule for today: when a result surprises you, check what actually served it before you touch the prompt</a:t>
+            </a:r>
+          </a:p>
+        </p:txBody>
+      </p:sp>
+    </p:spTree>
+  </p:cSld>
+  <p:clrMapOvr>
+    <a:masterClrMapping/>
+  </p:clrMapOvr>
+</p:sld>
+</file>
+
+<file path=ppt/slides/slide46.xml><?xml version="1.0" encoding="utf-8"?>
+<p:sld xmlns:a="http://schemas.openxmlformats.org/drawingml/2006/main" xmlns:p="http://schemas.openxmlformats.org/presentationml/2006/main" xmlns:r="http://schemas.openxmlformats.org/officeDocument/2006/relationships">
+  <p:cSld>
+    <p:spTree>
+      <p:nvGrpSpPr>
+        <p:cNvPr id="1" name=""/>
+        <p:cNvGrpSpPr/>
+        <p:nvPr/>
+      </p:nvGrpSpPr>
+      <p:grpSpPr/>
+      <p:sp>
+        <p:nvSpPr>
+          <p:cNvPr id="2" name="TextBox 1"/>
+          <p:cNvSpPr txBox="1"/>
+          <p:nvPr/>
+        </p:nvSpPr>
+        <p:spPr>
+          <a:xfrm>
+            <a:off x="658368" y="347472"/>
+            <a:ext cx="9601200" cy="237744"/>
+          </a:xfrm>
+          <a:prstGeom prst="rect">
+            <a:avLst/>
+          </a:prstGeom>
+          <a:noFill/>
+        </p:spPr>
+        <p:txBody>
+          <a:bodyPr wrap="square" lIns="0" rIns="0" tIns="0" bIns="0" anchor="ctr">
+            <a:spAutoFit/>
+          </a:bodyPr>
+          <a:lstStyle/>
+          <a:p>
+            <a:r>
+              <a:rPr sz="1000" b="1" spc="160">
+                <a:solidFill>
+                  <a:srgbClr val="E4572E"/>
+                </a:solidFill>
+                <a:latin typeface="Calibri"/>
+              </a:rPr>
+              <a:t>BLOCK 2 · RELIABILITY: SCHEMAS, EVALS, TOOLS</a:t>
+            </a:r>
+          </a:p>
+        </p:txBody>
+      </p:sp>
+      <p:sp>
+        <p:nvSpPr>
+          <p:cNvPr id="3" name="TextBox 2"/>
+          <p:cNvSpPr txBox="1"/>
+          <p:nvPr/>
+        </p:nvSpPr>
+        <p:spPr>
+          <a:xfrm>
+            <a:off x="658368" y="694944"/>
+            <a:ext cx="10872216" cy="786384"/>
+          </a:xfrm>
+          <a:prstGeom prst="rect">
+            <a:avLst/>
+          </a:prstGeom>
+          <a:noFill/>
+        </p:spPr>
+        <p:txBody>
+          <a:bodyPr wrap="square" lIns="0" rIns="0" tIns="0" bIns="0" anchor="ctr">
+            <a:spAutoFit/>
+          </a:bodyPr>
+          <a:lstStyle/>
+          <a:p>
+            <a:r>
+              <a:rPr sz="3000" b="1">
+                <a:solidFill>
+                  <a:srgbClr val="1B2227"/>
+                </a:solidFill>
+                <a:latin typeface="Cambria"/>
+              </a:rPr>
+              <a:t>Router gotchas, in the order you will hit them</a:t>
+            </a:r>
+          </a:p>
+        </p:txBody>
+      </p:sp>
+      <p:sp>
+        <p:nvSpPr>
+          <p:cNvPr id="4" name="Rounded Rectangle 3"/>
+          <p:cNvSpPr/>
+          <p:nvPr/>
+        </p:nvSpPr>
+        <p:spPr>
+          <a:xfrm>
+            <a:off x="658368" y="1664208"/>
+            <a:ext cx="10872216" cy="768096"/>
+          </a:xfrm>
+          <a:prstGeom prst="roundRect">
+            <a:avLst>
+              <a:gd name="adj" fmla="val 5000"/>
+            </a:avLst>
+          </a:prstGeom>
+          <a:solidFill>
+            <a:srgbClr val="F3F5F6"/>
+          </a:solidFill>
+          <a:ln>
+            <a:noFill/>
+          </a:ln>
+          <a:effectLst/>
+        </p:spPr>
+        <p:style>
+          <a:lnRef idx="1">
+            <a:schemeClr val="accent1"/>
+          </a:lnRef>
+          <a:fillRef idx="3">
+            <a:schemeClr val="accent1"/>
+          </a:fillRef>
+          <a:effectRef idx="2">
+            <a:schemeClr val="accent1"/>
+          </a:effectRef>
+          <a:fontRef idx="minor">
+            <a:schemeClr val="lt1"/>
+          </a:fontRef>
+        </p:style>
+        <p:txBody>
+          <a:bodyPr rtlCol="0" anchor="ctr"/>
+          <a:lstStyle/>
+          <a:p>
+            <a:pPr algn="ctr"/>
+          </a:p>
+        </p:txBody>
+      </p:sp>
+      <p:sp>
+        <p:nvSpPr>
+          <p:cNvPr id="5" name="Oval 4"/>
+          <p:cNvSpPr/>
+          <p:nvPr/>
+        </p:nvSpPr>
+        <p:spPr>
+          <a:xfrm>
+            <a:off x="896112" y="1837944"/>
+            <a:ext cx="420624" cy="420624"/>
+          </a:xfrm>
+          <a:prstGeom prst="ellipse">
+            <a:avLst/>
+          </a:prstGeom>
+          <a:solidFill>
+            <a:srgbClr val="E4572E"/>
+          </a:solidFill>
+          <a:ln>
+            <a:noFill/>
+          </a:ln>
+          <a:effectLst/>
+        </p:spPr>
+        <p:style>
+          <a:lnRef idx="1">
+            <a:schemeClr val="accent1"/>
+          </a:lnRef>
+          <a:fillRef idx="3">
+            <a:schemeClr val="accent1"/>
+          </a:fillRef>
+          <a:effectRef idx="2">
+            <a:schemeClr val="accent1"/>
+          </a:effectRef>
+          <a:fontRef idx="minor">
+            <a:schemeClr val="lt1"/>
+          </a:fontRef>
+        </p:style>
+        <p:txBody>
+          <a:bodyPr rtlCol="0" anchor="ctr"/>
+          <a:lstStyle/>
+          <a:p>
+            <a:pPr algn="ctr"/>
+          </a:p>
+        </p:txBody>
+      </p:sp>
+      <p:sp>
+        <p:nvSpPr>
+          <p:cNvPr id="6" name="TextBox 5"/>
+          <p:cNvSpPr txBox="1"/>
+          <p:nvPr/>
+        </p:nvSpPr>
+        <p:spPr>
+          <a:xfrm>
+            <a:off x="896112" y="1837944"/>
+            <a:ext cx="420624" cy="420624"/>
+          </a:xfrm>
+          <a:prstGeom prst="rect">
+            <a:avLst/>
+          </a:prstGeom>
+          <a:noFill/>
+        </p:spPr>
+        <p:txBody>
+          <a:bodyPr wrap="square" lIns="0" rIns="0" tIns="0" bIns="0" anchor="ctr">
+            <a:spAutoFit/>
+          </a:bodyPr>
+          <a:lstStyle/>
+          <a:p>
+            <a:pPr algn="ctr"/>
+            <a:r>
+              <a:rPr sz="1200" b="1">
+                <a:solidFill>
+                  <a:srgbClr val="FFFFFF"/>
+                </a:solidFill>
+                <a:latin typeface="Calibri"/>
+              </a:rPr>
+              <a:t>1</a:t>
+            </a:r>
+          </a:p>
+        </p:txBody>
+      </p:sp>
+      <p:sp>
+        <p:nvSpPr>
+          <p:cNvPr id="7" name="TextBox 6"/>
+          <p:cNvSpPr txBox="1"/>
+          <p:nvPr/>
+        </p:nvSpPr>
+        <p:spPr>
+          <a:xfrm>
+            <a:off x="1572768" y="1719072"/>
+            <a:ext cx="9683496" cy="658368"/>
+          </a:xfrm>
+          <a:prstGeom prst="rect">
+            <a:avLst/>
+          </a:prstGeom>
+          <a:noFill/>
+        </p:spPr>
+        <p:txBody>
+          <a:bodyPr wrap="square" lIns="0" rIns="0" tIns="0" bIns="0" anchor="ctr">
+            <a:spAutoFit/>
+          </a:bodyPr>
+          <a:lstStyle/>
+          <a:p>
+            <a:r>
+              <a:rPr sz="1500" b="1">
+                <a:solidFill>
+                  <a:srgbClr val="1B2227"/>
+                </a:solidFill>
+                <a:latin typeface="Calibri"/>
+              </a:rPr>
+              <a:t>Quota, not quality</a:t>
+            </a:r>
+            <a:r>
+              <a:rPr sz="1500" b="1">
+                <a:solidFill>
+                  <a:srgbClr val="1B2227"/>
+                </a:solidFill>
+                <a:latin typeface="Calibri"/>
+              </a:rPr>
+              <a:t> — </a:t>
+            </a:r>
+            <a:r>
+              <a:rPr sz="1500" b="0">
+                <a:solidFill>
+                  <a:srgbClr val="3A464E"/>
+                </a:solidFill>
+                <a:latin typeface="Calibri"/>
+              </a:rPr>
+              <a:t>roughly 20 requests per minute on free variants, and 50 per day until an account has $10 of lifetime credits (~1,000 after). A negative balance blocks free models too</a:t>
+            </a:r>
+          </a:p>
+        </p:txBody>
+      </p:sp>
+      <p:sp>
+        <p:nvSpPr>
+          <p:cNvPr id="8" name="Rounded Rectangle 7"/>
+          <p:cNvSpPr/>
+          <p:nvPr/>
+        </p:nvSpPr>
+        <p:spPr>
+          <a:xfrm>
+            <a:off x="658368" y="2578608"/>
+            <a:ext cx="10872216" cy="768096"/>
+          </a:xfrm>
+          <a:prstGeom prst="roundRect">
+            <a:avLst>
+              <a:gd name="adj" fmla="val 5000"/>
+            </a:avLst>
+          </a:prstGeom>
+          <a:solidFill>
+            <a:srgbClr val="F3F5F6"/>
+          </a:solidFill>
+          <a:ln>
+            <a:noFill/>
+          </a:ln>
+          <a:effectLst/>
+        </p:spPr>
+        <p:style>
+          <a:lnRef idx="1">
+            <a:schemeClr val="accent1"/>
+          </a:lnRef>
+          <a:fillRef idx="3">
+            <a:schemeClr val="accent1"/>
+          </a:fillRef>
+          <a:effectRef idx="2">
+            <a:schemeClr val="accent1"/>
+          </a:effectRef>
+          <a:fontRef idx="minor">
+            <a:schemeClr val="lt1"/>
+          </a:fontRef>
+        </p:style>
+        <p:txBody>
+          <a:bodyPr rtlCol="0" anchor="ctr"/>
+          <a:lstStyle/>
+          <a:p>
+            <a:pPr algn="ctr"/>
+          </a:p>
+        </p:txBody>
+      </p:sp>
+      <p:sp>
+        <p:nvSpPr>
+          <p:cNvPr id="9" name="Oval 8"/>
+          <p:cNvSpPr/>
+          <p:nvPr/>
+        </p:nvSpPr>
+        <p:spPr>
+          <a:xfrm>
+            <a:off x="896112" y="2752344"/>
+            <a:ext cx="420624" cy="420624"/>
+          </a:xfrm>
+          <a:prstGeom prst="ellipse">
+            <a:avLst/>
+          </a:prstGeom>
+          <a:solidFill>
+            <a:srgbClr val="17877C"/>
+          </a:solidFill>
+          <a:ln>
+            <a:noFill/>
+          </a:ln>
+          <a:effectLst/>
+        </p:spPr>
+        <p:style>
+          <a:lnRef idx="1">
+            <a:schemeClr val="accent1"/>
+          </a:lnRef>
+          <a:fillRef idx="3">
+            <a:schemeClr val="accent1"/>
+          </a:fillRef>
+          <a:effectRef idx="2">
+            <a:schemeClr val="accent1"/>
+          </a:effectRef>
+          <a:fontRef idx="minor">
+            <a:schemeClr val="lt1"/>
+          </a:fontRef>
+        </p:style>
+        <p:txBody>
+          <a:bodyPr rtlCol="0" anchor="ctr"/>
+          <a:lstStyle/>
+          <a:p>
+            <a:pPr algn="ctr"/>
+          </a:p>
+        </p:txBody>
+      </p:sp>
+      <p:sp>
+        <p:nvSpPr>
+          <p:cNvPr id="10" name="TextBox 9"/>
+          <p:cNvSpPr txBox="1"/>
+          <p:nvPr/>
+        </p:nvSpPr>
+        <p:spPr>
+          <a:xfrm>
+            <a:off x="896112" y="2752344"/>
+            <a:ext cx="420624" cy="420624"/>
+          </a:xfrm>
+          <a:prstGeom prst="rect">
+            <a:avLst/>
+          </a:prstGeom>
+          <a:noFill/>
+        </p:spPr>
+        <p:txBody>
+          <a:bodyPr wrap="square" lIns="0" rIns="0" tIns="0" bIns="0" anchor="ctr">
+            <a:spAutoFit/>
+          </a:bodyPr>
+          <a:lstStyle/>
+          <a:p>
+            <a:pPr algn="ctr"/>
+            <a:r>
+              <a:rPr sz="1200" b="1">
+                <a:solidFill>
+                  <a:srgbClr val="FFFFFF"/>
+                </a:solidFill>
+                <a:latin typeface="Calibri"/>
+              </a:rPr>
+              <a:t>2</a:t>
+            </a:r>
+          </a:p>
+        </p:txBody>
+      </p:sp>
+      <p:sp>
+        <p:nvSpPr>
+          <p:cNvPr id="11" name="TextBox 10"/>
+          <p:cNvSpPr txBox="1"/>
+          <p:nvPr/>
+        </p:nvSpPr>
+        <p:spPr>
+          <a:xfrm>
+            <a:off x="1572768" y="2633472"/>
+            <a:ext cx="9683496" cy="658368"/>
+          </a:xfrm>
+          <a:prstGeom prst="rect">
+            <a:avLst/>
+          </a:prstGeom>
+          <a:noFill/>
+        </p:spPr>
+        <p:txBody>
+          <a:bodyPr wrap="square" lIns="0" rIns="0" tIns="0" bIns="0" anchor="ctr">
+            <a:spAutoFit/>
+          </a:bodyPr>
+          <a:lstStyle/>
+          <a:p>
+            <a:r>
+              <a:rPr sz="1500" b="1">
+                <a:solidFill>
+                  <a:srgbClr val="1B2227"/>
+                </a:solidFill>
+                <a:latin typeface="Calibri"/>
+              </a:rPr>
+              <a:t>"Supports tools" is a claim</a:t>
+            </a:r>
+            <a:r>
+              <a:rPr sz="1500" b="1">
+                <a:solidFill>
+                  <a:srgbClr val="1B2227"/>
+                </a:solidFill>
+                <a:latin typeface="Calibri"/>
+              </a:rPr>
+              <a:t> — </a:t>
+            </a:r>
+            <a:r>
+              <a:rPr sz="1500" b="0">
+                <a:solidFill>
+                  <a:srgbClr val="3A464E"/>
+                </a:solidFill>
+                <a:latin typeface="Calibri"/>
+              </a:rPr>
+              <a:t>the catalog flag is metadata, not a test. No endpoints found that support tool use on a tool-capable model is a routing answer, not your bug</a:t>
+            </a:r>
+          </a:p>
+        </p:txBody>
+      </p:sp>
+      <p:sp>
+        <p:nvSpPr>
+          <p:cNvPr id="12" name="Rounded Rectangle 11"/>
+          <p:cNvSpPr/>
+          <p:nvPr/>
+        </p:nvSpPr>
+        <p:spPr>
+          <a:xfrm>
+            <a:off x="658368" y="3493008"/>
+            <a:ext cx="10872216" cy="768096"/>
+          </a:xfrm>
+          <a:prstGeom prst="roundRect">
+            <a:avLst>
+              <a:gd name="adj" fmla="val 5000"/>
+            </a:avLst>
+          </a:prstGeom>
+          <a:solidFill>
+            <a:srgbClr val="F3F5F6"/>
+          </a:solidFill>
+          <a:ln>
+            <a:noFill/>
+          </a:ln>
+          <a:effectLst/>
+        </p:spPr>
+        <p:style>
+          <a:lnRef idx="1">
+            <a:schemeClr val="accent1"/>
+          </a:lnRef>
+          <a:fillRef idx="3">
+            <a:schemeClr val="accent1"/>
+          </a:fillRef>
+          <a:effectRef idx="2">
+            <a:schemeClr val="accent1"/>
+          </a:effectRef>
+          <a:fontRef idx="minor">
+            <a:schemeClr val="lt1"/>
+          </a:fontRef>
+        </p:style>
+        <p:txBody>
+          <a:bodyPr rtlCol="0" anchor="ctr"/>
+          <a:lstStyle/>
+          <a:p>
+            <a:pPr algn="ctr"/>
+          </a:p>
+        </p:txBody>
+      </p:sp>
+      <p:sp>
+        <p:nvSpPr>
+          <p:cNvPr id="13" name="Oval 12"/>
+          <p:cNvSpPr/>
+          <p:nvPr/>
+        </p:nvSpPr>
+        <p:spPr>
+          <a:xfrm>
+            <a:off x="896112" y="3666744"/>
+            <a:ext cx="420624" cy="420624"/>
+          </a:xfrm>
+          <a:prstGeom prst="ellipse">
+            <a:avLst/>
+          </a:prstGeom>
+          <a:solidFill>
+            <a:srgbClr val="E4572E"/>
+          </a:solidFill>
+          <a:ln>
+            <a:noFill/>
+          </a:ln>
+          <a:effectLst/>
+        </p:spPr>
+        <p:style>
+          <a:lnRef idx="1">
+            <a:schemeClr val="accent1"/>
+          </a:lnRef>
+          <a:fillRef idx="3">
+            <a:schemeClr val="accent1"/>
+          </a:fillRef>
+          <a:effectRef idx="2">
+            <a:schemeClr val="accent1"/>
+          </a:effectRef>
+          <a:fontRef idx="minor">
+            <a:schemeClr val="lt1"/>
+          </a:fontRef>
+        </p:style>
+        <p:txBody>
+          <a:bodyPr rtlCol="0" anchor="ctr"/>
+          <a:lstStyle/>
+          <a:p>
+            <a:pPr algn="ctr"/>
+          </a:p>
+        </p:txBody>
+      </p:sp>
+      <p:sp>
+        <p:nvSpPr>
+          <p:cNvPr id="14" name="TextBox 13"/>
+          <p:cNvSpPr txBox="1"/>
+          <p:nvPr/>
+        </p:nvSpPr>
+        <p:spPr>
+          <a:xfrm>
+            <a:off x="896112" y="3666744"/>
+            <a:ext cx="420624" cy="420624"/>
+          </a:xfrm>
+          <a:prstGeom prst="rect">
+            <a:avLst/>
+          </a:prstGeom>
+          <a:noFill/>
+        </p:spPr>
+        <p:txBody>
+          <a:bodyPr wrap="square" lIns="0" rIns="0" tIns="0" bIns="0" anchor="ctr">
+            <a:spAutoFit/>
+          </a:bodyPr>
+          <a:lstStyle/>
+          <a:p>
+            <a:pPr algn="ctr"/>
+            <a:r>
+              <a:rPr sz="1200" b="1">
+                <a:solidFill>
+                  <a:srgbClr val="FFFFFF"/>
+                </a:solidFill>
+                <a:latin typeface="Calibri"/>
+              </a:rPr>
+              <a:t>3</a:t>
+            </a:r>
+          </a:p>
+        </p:txBody>
+      </p:sp>
+      <p:sp>
+        <p:nvSpPr>
+          <p:cNvPr id="15" name="TextBox 14"/>
+          <p:cNvSpPr txBox="1"/>
+          <p:nvPr/>
+        </p:nvSpPr>
+        <p:spPr>
+          <a:xfrm>
+            <a:off x="1572768" y="3547872"/>
+            <a:ext cx="9683496" cy="658368"/>
+          </a:xfrm>
+          <a:prstGeom prst="rect">
+            <a:avLst/>
+          </a:prstGeom>
+          <a:noFill/>
+        </p:spPr>
+        <p:txBody>
+          <a:bodyPr wrap="square" lIns="0" rIns="0" tIns="0" bIns="0" anchor="ctr">
+            <a:spAutoFit/>
+          </a:bodyPr>
+          <a:lstStyle/>
+          <a:p>
+            <a:r>
+              <a:rPr sz="1500" b="1">
+                <a:solidFill>
+                  <a:srgbClr val="1B2227"/>
+                </a:solidFill>
+                <a:latin typeface="Calibri"/>
+              </a:rPr>
+              <a:t>Model ids retire without notice</a:t>
+            </a:r>
+            <a:r>
+              <a:rPr sz="1500" b="1">
+                <a:solidFill>
+                  <a:srgbClr val="1B2227"/>
+                </a:solidFill>
+                <a:latin typeface="Calibri"/>
+              </a:rPr>
+              <a:t> — </a:t>
+            </a:r>
+            <a:r>
+              <a:rPr sz="1500" b="0">
+                <a:solidFill>
+                  <a:srgbClr val="3A464E"/>
+                </a:solidFill>
+                <a:latin typeface="Calibri"/>
+              </a:rPr>
+              <a:t>Lab 0's model-list cell exists for exactly this. Check it the morning you run, not the week before</a:t>
+            </a:r>
+          </a:p>
+        </p:txBody>
+      </p:sp>
+      <p:sp>
+        <p:nvSpPr>
+          <p:cNvPr id="16" name="Rounded Rectangle 15"/>
+          <p:cNvSpPr/>
+          <p:nvPr/>
+        </p:nvSpPr>
+        <p:spPr>
+          <a:xfrm>
+            <a:off x="658368" y="4407408"/>
+            <a:ext cx="10872216" cy="768096"/>
+          </a:xfrm>
+          <a:prstGeom prst="roundRect">
+            <a:avLst>
+              <a:gd name="adj" fmla="val 5000"/>
+            </a:avLst>
+          </a:prstGeom>
+          <a:solidFill>
+            <a:srgbClr val="F3F5F6"/>
+          </a:solidFill>
+          <a:ln>
+            <a:noFill/>
+          </a:ln>
+          <a:effectLst/>
+        </p:spPr>
+        <p:style>
+          <a:lnRef idx="1">
+            <a:schemeClr val="accent1"/>
+          </a:lnRef>
+          <a:fillRef idx="3">
+            <a:schemeClr val="accent1"/>
+          </a:fillRef>
+          <a:effectRef idx="2">
+            <a:schemeClr val="accent1"/>
+          </a:effectRef>
+          <a:fontRef idx="minor">
+            <a:schemeClr val="lt1"/>
+          </a:fontRef>
+        </p:style>
+        <p:txBody>
+          <a:bodyPr rtlCol="0" anchor="ctr"/>
+          <a:lstStyle/>
+          <a:p>
+            <a:pPr algn="ctr"/>
+          </a:p>
+        </p:txBody>
+      </p:sp>
+      <p:sp>
+        <p:nvSpPr>
+          <p:cNvPr id="17" name="Oval 16"/>
+          <p:cNvSpPr/>
+          <p:nvPr/>
+        </p:nvSpPr>
+        <p:spPr>
+          <a:xfrm>
+            <a:off x="896112" y="4581144"/>
+            <a:ext cx="420624" cy="420624"/>
+          </a:xfrm>
+          <a:prstGeom prst="ellipse">
+            <a:avLst/>
+          </a:prstGeom>
+          <a:solidFill>
+            <a:srgbClr val="17877C"/>
+          </a:solidFill>
+          <a:ln>
+            <a:noFill/>
+          </a:ln>
+          <a:effectLst/>
+        </p:spPr>
+        <p:style>
+          <a:lnRef idx="1">
+            <a:schemeClr val="accent1"/>
+          </a:lnRef>
+          <a:fillRef idx="3">
+            <a:schemeClr val="accent1"/>
+          </a:fillRef>
+          <a:effectRef idx="2">
+            <a:schemeClr val="accent1"/>
+          </a:effectRef>
+          <a:fontRef idx="minor">
+            <a:schemeClr val="lt1"/>
+          </a:fontRef>
+        </p:style>
+        <p:txBody>
+          <a:bodyPr rtlCol="0" anchor="ctr"/>
+          <a:lstStyle/>
+          <a:p>
+            <a:pPr algn="ctr"/>
+          </a:p>
+        </p:txBody>
+      </p:sp>
+      <p:sp>
+        <p:nvSpPr>
+          <p:cNvPr id="18" name="TextBox 17"/>
+          <p:cNvSpPr txBox="1"/>
+          <p:nvPr/>
+        </p:nvSpPr>
+        <p:spPr>
+          <a:xfrm>
+            <a:off x="896112" y="4581144"/>
+            <a:ext cx="420624" cy="420624"/>
+          </a:xfrm>
+          <a:prstGeom prst="rect">
+            <a:avLst/>
+          </a:prstGeom>
+          <a:noFill/>
+        </p:spPr>
+        <p:txBody>
+          <a:bodyPr wrap="square" lIns="0" rIns="0" tIns="0" bIns="0" anchor="ctr">
+            <a:spAutoFit/>
+          </a:bodyPr>
+          <a:lstStyle/>
+          <a:p>
+            <a:pPr algn="ctr"/>
+            <a:r>
+              <a:rPr sz="1200" b="1">
+                <a:solidFill>
+                  <a:srgbClr val="FFFFFF"/>
+                </a:solidFill>
+                <a:latin typeface="Calibri"/>
+              </a:rPr>
+              <a:t>4</a:t>
+            </a:r>
+          </a:p>
+        </p:txBody>
+      </p:sp>
+      <p:sp>
+        <p:nvSpPr>
+          <p:cNvPr id="19" name="TextBox 18"/>
+          <p:cNvSpPr txBox="1"/>
+          <p:nvPr/>
+        </p:nvSpPr>
+        <p:spPr>
+          <a:xfrm>
+            <a:off x="1572768" y="4462272"/>
+            <a:ext cx="9683496" cy="658368"/>
+          </a:xfrm>
+          <a:prstGeom prst="rect">
+            <a:avLst/>
+          </a:prstGeom>
+          <a:noFill/>
+        </p:spPr>
+        <p:txBody>
+          <a:bodyPr wrap="square" lIns="0" rIns="0" tIns="0" bIns="0" anchor="ctr">
+            <a:spAutoFit/>
+          </a:bodyPr>
+          <a:lstStyle/>
+          <a:p>
+            <a:r>
+              <a:rPr sz="1500" b="1">
+                <a:solidFill>
+                  <a:srgbClr val="1B2227"/>
+                </a:solidFill>
+                <a:latin typeface="Calibri"/>
+              </a:rPr>
+              <a:t>Silent provider swap</a:t>
+            </a:r>
+            <a:r>
+              <a:rPr sz="1500" b="1">
+                <a:solidFill>
+                  <a:srgbClr val="1B2227"/>
+                </a:solidFill>
+                <a:latin typeface="Calibri"/>
+              </a:rPr>
+              <a:t> — </a:t>
+            </a:r>
+            <a:r>
+              <a:rPr sz="1500" b="0">
+                <a:solidFill>
+                  <a:srgbClr val="3A464E"/>
+                </a:solidFill>
+                <a:latin typeface="Calibri"/>
+              </a:rPr>
+              <a:t>same id, different provider, different quantization, different answer. Log what served the call</a:t>
+            </a:r>
+          </a:p>
+        </p:txBody>
+      </p:sp>
+      <p:sp>
+        <p:nvSpPr>
+          <p:cNvPr id="20" name="Rounded Rectangle 19"/>
+          <p:cNvSpPr/>
+          <p:nvPr/>
+        </p:nvSpPr>
+        <p:spPr>
+          <a:xfrm>
+            <a:off x="658368" y="5321808"/>
+            <a:ext cx="10872216" cy="768096"/>
+          </a:xfrm>
+          <a:prstGeom prst="roundRect">
+            <a:avLst>
+              <a:gd name="adj" fmla="val 5000"/>
+            </a:avLst>
+          </a:prstGeom>
+          <a:solidFill>
+            <a:srgbClr val="F3F5F6"/>
+          </a:solidFill>
+          <a:ln>
+            <a:noFill/>
+          </a:ln>
+          <a:effectLst/>
+        </p:spPr>
+        <p:style>
+          <a:lnRef idx="1">
+            <a:schemeClr val="accent1"/>
+          </a:lnRef>
+          <a:fillRef idx="3">
+            <a:schemeClr val="accent1"/>
+          </a:fillRef>
+          <a:effectRef idx="2">
+            <a:schemeClr val="accent1"/>
+          </a:effectRef>
+          <a:fontRef idx="minor">
+            <a:schemeClr val="lt1"/>
+          </a:fontRef>
+        </p:style>
+        <p:txBody>
+          <a:bodyPr rtlCol="0" anchor="ctr"/>
+          <a:lstStyle/>
+          <a:p>
+            <a:pPr algn="ctr"/>
+          </a:p>
+        </p:txBody>
+      </p:sp>
+      <p:sp>
+        <p:nvSpPr>
+          <p:cNvPr id="21" name="Oval 20"/>
+          <p:cNvSpPr/>
+          <p:nvPr/>
+        </p:nvSpPr>
+        <p:spPr>
+          <a:xfrm>
+            <a:off x="896112" y="5495544"/>
+            <a:ext cx="420624" cy="420624"/>
+          </a:xfrm>
+          <a:prstGeom prst="ellipse">
+            <a:avLst/>
+          </a:prstGeom>
+          <a:solidFill>
+            <a:srgbClr val="E4572E"/>
+          </a:solidFill>
+          <a:ln>
+            <a:noFill/>
+          </a:ln>
+          <a:effectLst/>
+        </p:spPr>
+        <p:style>
+          <a:lnRef idx="1">
+            <a:schemeClr val="accent1"/>
+          </a:lnRef>
+          <a:fillRef idx="3">
+            <a:schemeClr val="accent1"/>
+          </a:fillRef>
+          <a:effectRef idx="2">
+            <a:schemeClr val="accent1"/>
+          </a:effectRef>
+          <a:fontRef idx="minor">
+            <a:schemeClr val="lt1"/>
+          </a:fontRef>
+        </p:style>
+        <p:txBody>
+          <a:bodyPr rtlCol="0" anchor="ctr"/>
+          <a:lstStyle/>
+          <a:p>
+            <a:pPr algn="ctr"/>
+          </a:p>
+        </p:txBody>
+      </p:sp>
+      <p:sp>
+        <p:nvSpPr>
+          <p:cNvPr id="22" name="TextBox 21"/>
+          <p:cNvSpPr txBox="1"/>
+          <p:nvPr/>
+        </p:nvSpPr>
+        <p:spPr>
+          <a:xfrm>
+            <a:off x="896112" y="5495544"/>
+            <a:ext cx="420624" cy="420624"/>
+          </a:xfrm>
+          <a:prstGeom prst="rect">
+            <a:avLst/>
+          </a:prstGeom>
+          <a:noFill/>
+        </p:spPr>
+        <p:txBody>
+          <a:bodyPr wrap="square" lIns="0" rIns="0" tIns="0" bIns="0" anchor="ctr">
+            <a:spAutoFit/>
+          </a:bodyPr>
+          <a:lstStyle/>
+          <a:p>
+            <a:pPr algn="ctr"/>
+            <a:r>
+              <a:rPr sz="1200" b="1">
+                <a:solidFill>
+                  <a:srgbClr val="FFFFFF"/>
+                </a:solidFill>
+                <a:latin typeface="Calibri"/>
+              </a:rPr>
+              <a:t>5</a:t>
+            </a:r>
+          </a:p>
+        </p:txBody>
+      </p:sp>
+      <p:sp>
+        <p:nvSpPr>
+          <p:cNvPr id="23" name="TextBox 22"/>
+          <p:cNvSpPr txBox="1"/>
+          <p:nvPr/>
+        </p:nvSpPr>
+        <p:spPr>
+          <a:xfrm>
+            <a:off x="1572768" y="5376672"/>
+            <a:ext cx="9683496" cy="658368"/>
+          </a:xfrm>
+          <a:prstGeom prst="rect">
+            <a:avLst/>
+          </a:prstGeom>
+          <a:noFill/>
+        </p:spPr>
+        <p:txBody>
+          <a:bodyPr wrap="square" lIns="0" rIns="0" tIns="0" bIns="0" anchor="ctr">
+            <a:spAutoFit/>
+          </a:bodyPr>
+          <a:lstStyle/>
+          <a:p>
+            <a:r>
+              <a:rPr sz="1500" b="1">
+                <a:solidFill>
+                  <a:srgbClr val="1B2227"/>
+                </a:solidFill>
+                <a:latin typeface="Calibri"/>
+              </a:rPr>
+              <a:t>Free routes may log your prompts</a:t>
+            </a:r>
+            <a:r>
+              <a:rPr sz="1500" b="1">
+                <a:solidFill>
+                  <a:srgbClr val="1B2227"/>
+                </a:solidFill>
+                <a:latin typeface="Calibri"/>
+              </a:rPr>
+              <a:t> — </a:t>
+            </a:r>
+            <a:r>
+              <a:rPr sz="1500" b="0">
+                <a:solidFill>
+                  <a:srgbClr val="3A464E"/>
+                </a:solidFill>
+                <a:latin typeface="Calibri"/>
+              </a:rPr>
+              <a:t>nothing from a client, a patient record, or a federal system goes through a free tier today or ever</a:t>
+            </a:r>
+          </a:p>
+        </p:txBody>
+      </p:sp>
+    </p:spTree>
+  </p:cSld>
+  <p:clrMapOvr>
+    <a:masterClrMapping/>
+  </p:clrMapOvr>
+</p:sld>
+</file>
+
 <file path=ppt/slides/slide5.xml><?xml version="1.0" encoding="utf-8"?>
 <p:sld xmlns:a="http://schemas.openxmlformats.org/drawingml/2006/main" xmlns:r="http://schemas.openxmlformats.org/officeDocument/2006/relationships" xmlns:p="http://schemas.openxmlformats.org/presentationml/2006/main">
   <p:cSld name="Slide 5">
@@ -30036,7 +31689,7 @@
                 <a:ea typeface="Calibri" pitchFamily="34" charset="-122"/>
                 <a:cs typeface="Calibri" pitchFamily="34" charset="-120"/>
               </a:rPr>
-              <a:t>8</a:t>
+              <a:t>9</a:t>
             </a:r>
             <a:endParaRPr lang="en-US" sz="950" dirty="0"/>
           </a:p>
@@ -30590,7 +32243,7 @@
                 <a:ea typeface="Calibri" pitchFamily="34" charset="-122"/>
                 <a:cs typeface="Calibri" pitchFamily="34" charset="-120"/>
               </a:rPr>
-              <a:t>9</a:t>
+              <a:t>10</a:t>
             </a:r>
             <a:endParaRPr lang="en-US" sz="950" dirty="0"/>
           </a:p>

</xml_diff>